<commit_message>
corrected a typo in lesson 7
</commit_message>
<xml_diff>
--- a/lesson_07-ux_and_ui_in_flutter/lesson_07-ux_and_ui_in_flutter.pptx
+++ b/lesson_07-ux_and_ui_in_flutter/lesson_07-ux_and_ui_in_flutter.pptx
@@ -234,7 +234,7 @@
           <a:p>
             <a:fld id="{251090E0-FB0C-49E9-9864-9F53EABEA96F}" type="datetimeFigureOut">
               <a:rPr lang="en-GB" smtClean="0"/>
-              <a:t>19/02/2026</a:t>
+              <a:t>27/02/2026</a:t>
             </a:fld>
             <a:endParaRPr lang="en-GB"/>
           </a:p>
@@ -5592,15 +5592,7 @@
           <a:p>
             <a:r>
               <a:rPr lang="en-US" dirty="0"/>
-              <a:t>In Flutter, Material is activated </a:t>
-            </a:r>
-            <a:r>
-              <a:rPr lang="en-US" dirty="0" err="1"/>
-              <a:t>providng</a:t>
-            </a:r>
-            <a:r>
-              <a:rPr lang="en-US" dirty="0"/>
-              <a:t> a </a:t>
+              <a:t>In Flutter, Material is activated providing a </a:t>
             </a:r>
             <a:r>
               <a:rPr lang="en-US" dirty="0" err="1">

</xml_diff>

<commit_message>
added lesson 22 and 23 + updates
</commit_message>
<xml_diff>
--- a/lesson_07-ux_and_ui_in_flutter/lesson_07-ux_and_ui_in_flutter.pptx
+++ b/lesson_07-ux_and_ui_in_flutter/lesson_07-ux_and_ui_in_flutter.pptx
@@ -234,7 +234,7 @@
           <a:p>
             <a:fld id="{251090E0-FB0C-49E9-9864-9F53EABEA96F}" type="datetimeFigureOut">
               <a:rPr lang="en-GB" smtClean="0"/>
-              <a:t>27/02/2026</a:t>
+              <a:t>20/03/2026</a:t>
             </a:fld>
             <a:endParaRPr lang="en-GB"/>
           </a:p>
@@ -6158,15 +6158,7 @@
           <a:p>
             <a:r>
               <a:rPr lang="en-US" dirty="0"/>
-              <a:t>This </a:t>
-            </a:r>
-            <a:r>
-              <a:rPr lang="en-US" dirty="0" err="1"/>
-              <a:t>allos</a:t>
-            </a:r>
-            <a:r>
-              <a:rPr lang="en-US" dirty="0"/>
-              <a:t> also to express priorities.</a:t>
+              <a:t>This allows also to express priorities.</a:t>
             </a:r>
             <a:endParaRPr lang="it-IT" dirty="0"/>
           </a:p>

</xml_diff>